<commit_message>
Brochure: remove team photo, replace tool photo strip with pipe cutter block
Co-Authored-By: Claude Sonnet 5.5 <noreply@anthropic.com>
Claude-Session: https://claude.ai/code/session_01XPwnZBmWUGhvYebrP3X3Z2
</commit_message>
<xml_diff>
--- a/Plaquette_Enedril_2026.pptx
+++ b/Plaquette_Enedril_2026.pptx
@@ -5656,9 +5656,76 @@
           </a:p>
         </p:txBody>
       </p:sp>
+      <p:sp>
+        <p:nvSpPr>
+          <p:cNvPr id="23" name="TextBox 22"/>
+          <p:cNvSpPr txBox="1"/>
+          <p:nvPr/>
+        </p:nvSpPr>
+        <p:spPr>
+          <a:xfrm>
+            <a:off x="457200" y="5816600"/>
+            <a:ext cx="6642100" cy="127000"/>
+          </a:xfrm>
+          <a:prstGeom prst="rect">
+            <a:avLst/>
+          </a:prstGeom>
+          <a:noFill/>
+        </p:spPr>
+        <p:txBody>
+          <a:bodyPr wrap="square" lIns="0" rIns="0" tIns="0" bIns="0" anchor="t">
+            <a:spAutoFit/>
+          </a:bodyPr>
+          <a:lstStyle/>
+          <a:p>
+            <a:pPr algn="l">
+              <a:lnSpc>
+                <a:spcPts val="1040"/>
+              </a:lnSpc>
+              <a:spcAft>
+                <a:spcPts val="300"/>
+              </a:spcAft>
+            </a:pPr>
+            <a:r>
+              <a:rPr sz="1200" b="1" i="0">
+                <a:solidFill>
+                  <a:srgbClr val="194E9A"/>
+                </a:solidFill>
+                <a:latin typeface="Ubuntu Mono"/>
+                <a:ea typeface="Ubuntu Mono"/>
+                <a:cs typeface="Ubuntu Mono"/>
+                <a:sym typeface="Ubuntu Mono"/>
+              </a:rPr>
+              <a:t>A TEAM OF 33</a:t>
+            </a:r>
+          </a:p>
+          <a:p>
+            <a:pPr algn="l">
+              <a:lnSpc>
+                <a:spcPts val="1040"/>
+              </a:lnSpc>
+              <a:spcAft>
+                <a:spcPts val="300"/>
+              </a:spcAft>
+            </a:pPr>
+            <a:r>
+              <a:rPr sz="780" b="0" i="0">
+                <a:solidFill>
+                  <a:srgbClr val="0B1B2E"/>
+                </a:solidFill>
+                <a:latin typeface="Ubuntu Mono"/>
+                <a:ea typeface="Ubuntu Mono"/>
+                <a:cs typeface="Ubuntu Mono"/>
+                <a:sym typeface="Ubuntu Mono"/>
+              </a:rPr>
+              <a:t>Directional Drillers, MWD Engineers, fishing engineers, mechanics and welders, working from Lons and on your site. We are known for being fast, flexible and easy to work with.</a:t>
+            </a:r>
+          </a:p>
+        </p:txBody>
+      </p:sp>
       <p:pic>
         <p:nvPicPr>
-          <p:cNvPr id="23" name="Picture 22" descr="_c_team_300_157.png"/>
+          <p:cNvPr id="24" name="Picture 23" descr="_c_w4_127_112.png"/>
           <p:cNvPicPr>
             <a:picLocks noChangeAspect="1"/>
           </p:cNvPicPr>
@@ -5672,106 +5739,89 @@
         </p:blipFill>
         <p:spPr>
           <a:xfrm>
-            <a:off x="457200" y="5816600"/>
-            <a:ext cx="3810000" cy="1993900"/>
+            <a:off x="457200" y="6426200"/>
+            <a:ext cx="1612900" cy="1422400"/>
           </a:xfrm>
           <a:prstGeom prst="rect">
             <a:avLst/>
           </a:prstGeom>
         </p:spPr>
       </p:pic>
-      <p:sp>
-        <p:nvSpPr>
-          <p:cNvPr id="24" name="TextBox 23"/>
-          <p:cNvSpPr txBox="1"/>
-          <p:nvPr/>
-        </p:nvSpPr>
-        <p:spPr>
-          <a:xfrm>
-            <a:off x="4445000" y="5816600"/>
-            <a:ext cx="2654300" cy="127000"/>
-          </a:xfrm>
-          <a:prstGeom prst="rect">
-            <a:avLst/>
-          </a:prstGeom>
-          <a:noFill/>
-        </p:spPr>
-        <p:txBody>
-          <a:bodyPr wrap="square" lIns="0" rIns="0" tIns="0" bIns="0" anchor="t">
-            <a:spAutoFit/>
-          </a:bodyPr>
-          <a:lstStyle/>
-          <a:p>
-            <a:pPr algn="l">
-              <a:lnSpc>
-                <a:spcPts val="1019"/>
-              </a:lnSpc>
-              <a:spcAft>
-                <a:spcPts val="400"/>
-              </a:spcAft>
-            </a:pPr>
-            <a:r>
-              <a:rPr sz="1200" b="1" i="0">
-                <a:solidFill>
-                  <a:srgbClr val="194E9A"/>
-                </a:solidFill>
-                <a:latin typeface="Ubuntu Mono"/>
-                <a:ea typeface="Ubuntu Mono"/>
-                <a:cs typeface="Ubuntu Mono"/>
-                <a:sym typeface="Ubuntu Mono"/>
-              </a:rPr>
-              <a:t>A TEAM OF 33</a:t>
-            </a:r>
-          </a:p>
-          <a:p>
-            <a:pPr algn="l">
-              <a:lnSpc>
-                <a:spcPts val="1019"/>
-              </a:lnSpc>
-              <a:spcAft>
-                <a:spcPts val="400"/>
-              </a:spcAft>
-            </a:pPr>
-            <a:r>
-              <a:rPr sz="760" b="0" i="0">
-                <a:solidFill>
-                  <a:srgbClr val="0B1B2E"/>
-                </a:solidFill>
-                <a:latin typeface="Ubuntu Mono"/>
-                <a:ea typeface="Ubuntu Mono"/>
-                <a:cs typeface="Ubuntu Mono"/>
-                <a:sym typeface="Ubuntu Mono"/>
-              </a:rPr>
-              <a:t>Directional Drillers, MWD Engineers, fishing engineers, mechanics and welders, working from Lons and on your site.</a:t>
-            </a:r>
-          </a:p>
-          <a:p>
-            <a:pPr algn="l">
-              <a:lnSpc>
-                <a:spcPts val="1019"/>
-              </a:lnSpc>
-              <a:spcAft>
-                <a:spcPts val="400"/>
-              </a:spcAft>
-            </a:pPr>
-            <a:r>
-              <a:rPr sz="760" b="1" i="0">
-                <a:solidFill>
-                  <a:srgbClr val="0F7FCB"/>
-                </a:solidFill>
-                <a:latin typeface="Ubuntu Mono"/>
-                <a:ea typeface="Ubuntu Mono"/>
-                <a:cs typeface="Ubuntu Mono"/>
-                <a:sym typeface="Ubuntu Mono"/>
-              </a:rPr>
-              <a:t>We are known for being fast, flexible and easy to work with.</a:t>
-            </a:r>
-          </a:p>
-        </p:txBody>
-      </p:sp>
-      <p:sp>
-        <p:nvSpPr>
-          <p:cNvPr id="25" name="Rectangle 24"/>
+      <p:pic>
+        <p:nvPicPr>
+          <p:cNvPr id="25" name="Picture 24" descr="_c_w3_127_112.png"/>
+          <p:cNvPicPr>
+            <a:picLocks noChangeAspect="1"/>
+          </p:cNvPicPr>
+          <p:nvPr/>
+        </p:nvPicPr>
+        <p:blipFill>
+          <a:blip r:embed="rId4"/>
+          <a:stretch>
+            <a:fillRect/>
+          </a:stretch>
+        </p:blipFill>
+        <p:spPr>
+          <a:xfrm>
+            <a:off x="2133600" y="6426200"/>
+            <a:ext cx="1612900" cy="1422400"/>
+          </a:xfrm>
+          <a:prstGeom prst="rect">
+            <a:avLst/>
+          </a:prstGeom>
+        </p:spPr>
+      </p:pic>
+      <p:pic>
+        <p:nvPicPr>
+          <p:cNvPr id="26" name="Picture 25" descr="_c_w1_127_112.png"/>
+          <p:cNvPicPr>
+            <a:picLocks noChangeAspect="1"/>
+          </p:cNvPicPr>
+          <p:nvPr/>
+        </p:nvPicPr>
+        <p:blipFill>
+          <a:blip r:embed="rId5"/>
+          <a:stretch>
+            <a:fillRect/>
+          </a:stretch>
+        </p:blipFill>
+        <p:spPr>
+          <a:xfrm>
+            <a:off x="3810000" y="6426200"/>
+            <a:ext cx="1612900" cy="1422400"/>
+          </a:xfrm>
+          <a:prstGeom prst="rect">
+            <a:avLst/>
+          </a:prstGeom>
+        </p:spPr>
+      </p:pic>
+      <p:pic>
+        <p:nvPicPr>
+          <p:cNvPr id="27" name="Picture 26" descr="_c_w2_127_112.png"/>
+          <p:cNvPicPr>
+            <a:picLocks noChangeAspect="1"/>
+          </p:cNvPicPr>
+          <p:nvPr/>
+        </p:nvPicPr>
+        <p:blipFill>
+          <a:blip r:embed="rId6"/>
+          <a:stretch>
+            <a:fillRect/>
+          </a:stretch>
+        </p:blipFill>
+        <p:spPr>
+          <a:xfrm>
+            <a:off x="5486400" y="6426200"/>
+            <a:ext cx="1612900" cy="1422400"/>
+          </a:xfrm>
+          <a:prstGeom prst="rect">
+            <a:avLst/>
+          </a:prstGeom>
+        </p:spPr>
+      </p:pic>
+      <p:sp>
+        <p:nvSpPr>
+          <p:cNvPr id="28" name="Rectangle 27"/>
           <p:cNvSpPr/>
           <p:nvPr/>
         </p:nvSpPr>
@@ -5800,7 +5850,7 @@
       </p:sp>
       <p:sp>
         <p:nvSpPr>
-          <p:cNvPr id="26" name="TextBox 25"/>
+          <p:cNvPr id="29" name="TextBox 28"/>
           <p:cNvSpPr txBox="1"/>
           <p:nvPr/>
         </p:nvSpPr>
@@ -5845,7 +5895,7 @@
       </p:sp>
       <p:sp>
         <p:nvSpPr>
-          <p:cNvPr id="27" name="TextBox 26"/>
+          <p:cNvPr id="30" name="TextBox 29"/>
           <p:cNvSpPr txBox="1"/>
           <p:nvPr/>
         </p:nvSpPr>
@@ -5890,7 +5940,7 @@
       </p:sp>
       <p:sp>
         <p:nvSpPr>
-          <p:cNvPr id="28" name="Rectangle 27"/>
+          <p:cNvPr id="31" name="Rectangle 30"/>
           <p:cNvSpPr/>
           <p:nvPr/>
         </p:nvSpPr>
@@ -5919,7 +5969,7 @@
       </p:sp>
       <p:sp>
         <p:nvSpPr>
-          <p:cNvPr id="29" name="TextBox 28"/>
+          <p:cNvPr id="32" name="TextBox 31"/>
           <p:cNvSpPr txBox="1"/>
           <p:nvPr/>
         </p:nvSpPr>
@@ -5964,7 +6014,7 @@
       </p:sp>
       <p:sp>
         <p:nvSpPr>
-          <p:cNvPr id="30" name="TextBox 29"/>
+          <p:cNvPr id="33" name="TextBox 32"/>
           <p:cNvSpPr txBox="1"/>
           <p:nvPr/>
         </p:nvSpPr>
@@ -6009,7 +6059,7 @@
       </p:sp>
       <p:sp>
         <p:nvSpPr>
-          <p:cNvPr id="31" name="Rectangle 30"/>
+          <p:cNvPr id="34" name="Rectangle 33"/>
           <p:cNvSpPr/>
           <p:nvPr/>
         </p:nvSpPr>
@@ -6038,7 +6088,7 @@
       </p:sp>
       <p:sp>
         <p:nvSpPr>
-          <p:cNvPr id="32" name="TextBox 31"/>
+          <p:cNvPr id="35" name="TextBox 34"/>
           <p:cNvSpPr txBox="1"/>
           <p:nvPr/>
         </p:nvSpPr>
@@ -6083,7 +6133,7 @@
       </p:sp>
       <p:sp>
         <p:nvSpPr>
-          <p:cNvPr id="33" name="TextBox 32"/>
+          <p:cNvPr id="36" name="TextBox 35"/>
           <p:cNvSpPr txBox="1"/>
           <p:nvPr/>
         </p:nvSpPr>
@@ -6128,7 +6178,7 @@
       </p:sp>
       <p:sp>
         <p:nvSpPr>
-          <p:cNvPr id="34" name="Rectangle 33"/>
+          <p:cNvPr id="37" name="Rectangle 36"/>
           <p:cNvSpPr/>
           <p:nvPr/>
         </p:nvSpPr>
@@ -6157,7 +6207,7 @@
       </p:sp>
       <p:sp>
         <p:nvSpPr>
-          <p:cNvPr id="35" name="TextBox 34"/>
+          <p:cNvPr id="38" name="TextBox 37"/>
           <p:cNvSpPr txBox="1"/>
           <p:nvPr/>
         </p:nvSpPr>
@@ -6202,7 +6252,7 @@
       </p:sp>
       <p:sp>
         <p:nvSpPr>
-          <p:cNvPr id="36" name="TextBox 35"/>
+          <p:cNvPr id="39" name="TextBox 38"/>
           <p:cNvSpPr txBox="1"/>
           <p:nvPr/>
         </p:nvSpPr>
@@ -6247,7 +6297,7 @@
       </p:sp>
       <p:sp>
         <p:nvSpPr>
-          <p:cNvPr id="37" name="Rectangle 36"/>
+          <p:cNvPr id="40" name="Rectangle 39"/>
           <p:cNvSpPr/>
           <p:nvPr/>
         </p:nvSpPr>
@@ -6276,14 +6326,14 @@
       </p:sp>
       <p:pic>
         <p:nvPicPr>
-          <p:cNvPr id="38" name="Picture 37" descr="_c_iso_82_82.png"/>
+          <p:cNvPr id="41" name="Picture 40" descr="_c_iso_82_82.png"/>
           <p:cNvPicPr>
             <a:picLocks noChangeAspect="1"/>
           </p:cNvPicPr>
           <p:nvPr/>
         </p:nvPicPr>
         <p:blipFill>
-          <a:blip r:embed="rId4"/>
+          <a:blip r:embed="rId7"/>
           <a:stretch>
             <a:fillRect/>
           </a:stretch>
@@ -6300,7 +6350,7 @@
       </p:pic>
       <p:sp>
         <p:nvSpPr>
-          <p:cNvPr id="39" name="TextBox 38"/>
+          <p:cNvPr id="42" name="TextBox 41"/>
           <p:cNvSpPr txBox="1"/>
           <p:nvPr/>
         </p:nvSpPr>
@@ -6433,7 +6483,7 @@
       </p:sp>
       <p:sp>
         <p:nvSpPr>
-          <p:cNvPr id="40" name="TextBox 39"/>
+          <p:cNvPr id="43" name="TextBox 42"/>
           <p:cNvSpPr txBox="1"/>
           <p:nvPr/>
         </p:nvSpPr>
@@ -6522,7 +6572,7 @@
       </p:sp>
       <p:sp>
         <p:nvSpPr>
-          <p:cNvPr id="41" name="Rectangle 40"/>
+          <p:cNvPr id="44" name="Rectangle 43"/>
           <p:cNvSpPr/>
           <p:nvPr/>
         </p:nvSpPr>
@@ -6551,7 +6601,7 @@
       </p:sp>
       <p:sp>
         <p:nvSpPr>
-          <p:cNvPr id="42" name="TextBox 41"/>
+          <p:cNvPr id="45" name="TextBox 44"/>
           <p:cNvSpPr txBox="1"/>
           <p:nvPr/>
         </p:nvSpPr>

</xml_diff>